<commit_message>
Add retail stores project
</commit_message>
<xml_diff>
--- a/PowerBI Assignment/Group 14 Tembo Hotel Presentation.pptx
+++ b/PowerBI Assignment/Group 14 Tembo Hotel Presentation.pptx
@@ -122,7 +122,7 @@
 <file path=ppt/revisionInfo.xml><?xml version="1.0" encoding="utf-8"?>
 <p1510:revInfo xmlns:a="http://schemas.openxmlformats.org/drawingml/2006/main" xmlns:r="http://schemas.openxmlformats.org/officeDocument/2006/relationships" xmlns:p1510="http://schemas.microsoft.com/office/powerpoint/2015/10/main">
   <p1510:revLst>
-    <p1510:client id="{866A2317-32B2-4D6D-99C4-47E5FE503A5E}" v="167" dt="2026-05-02T23:03:25.374"/>
+    <p1510:client id="{866A2317-32B2-4D6D-99C4-47E5FE503A5E}" v="168" dt="2026-05-21T17:16:09.332"/>
   </p1510:revLst>
 </p1510:revInfo>
 </file>
@@ -156,14 +156,6 @@
             <pc:docMk/>
             <pc:sldMk cId="3652765744" sldId="256"/>
             <ac:spMk id="3" creationId="{E81F8283-6937-49E8-ACC2-CCFEDDDE032E}"/>
-          </ac:spMkLst>
-        </pc:spChg>
-        <pc:spChg chg="add del mod">
-          <ac:chgData name="_ Nyabuto" userId="de7d4a1065fab06a" providerId="LiveId" clId="{1DF12B70-FCDA-45B6-8265-91C62AD6C63B}" dt="2026-05-02T23:01:05.585" v="1665" actId="478"/>
-          <ac:spMkLst>
-            <pc:docMk/>
-            <pc:sldMk cId="3652765744" sldId="256"/>
-            <ac:spMk id="5" creationId="{D3CAC3DD-4B1E-2D3C-5798-6AA1099F088F}"/>
           </ac:spMkLst>
         </pc:spChg>
       </pc:sldChg>
@@ -204,38 +196,6 @@
             <ac:spMk id="2" creationId="{0BEDEBDF-C82A-4B40-9FDA-B9E873A3FB01}"/>
           </ac:spMkLst>
         </pc:spChg>
-        <pc:spChg chg="del">
-          <ac:chgData name="_ Nyabuto" userId="de7d4a1065fab06a" providerId="LiveId" clId="{1DF12B70-FCDA-45B6-8265-91C62AD6C63B}" dt="2026-05-02T18:13:42.569" v="0" actId="26606"/>
-          <ac:spMkLst>
-            <pc:docMk/>
-            <pc:sldMk cId="2044519959" sldId="258"/>
-            <ac:spMk id="3" creationId="{1A28688F-4289-4AF9-9334-6886D45BD6C7}"/>
-          </ac:spMkLst>
-        </pc:spChg>
-        <pc:spChg chg="add del">
-          <ac:chgData name="_ Nyabuto" userId="de7d4a1065fab06a" providerId="LiveId" clId="{1DF12B70-FCDA-45B6-8265-91C62AD6C63B}" dt="2026-05-02T18:25:04.661" v="192" actId="26606"/>
-          <ac:spMkLst>
-            <pc:docMk/>
-            <pc:sldMk cId="2044519959" sldId="258"/>
-            <ac:spMk id="12" creationId="{D77CF7D5-36A3-4ED3-AE46-77E42D2AA7FD}"/>
-          </ac:spMkLst>
-        </pc:spChg>
-        <pc:spChg chg="add del">
-          <ac:chgData name="_ Nyabuto" userId="de7d4a1065fab06a" providerId="LiveId" clId="{1DF12B70-FCDA-45B6-8265-91C62AD6C63B}" dt="2026-05-02T18:25:26.498" v="194" actId="26606"/>
-          <ac:spMkLst>
-            <pc:docMk/>
-            <pc:sldMk cId="2044519959" sldId="258"/>
-            <ac:spMk id="15" creationId="{6D58954F-C5AC-4BE0-811D-8DFE18E3506B}"/>
-          </ac:spMkLst>
-        </pc:spChg>
-        <pc:spChg chg="add del">
-          <ac:chgData name="_ Nyabuto" userId="de7d4a1065fab06a" providerId="LiveId" clId="{1DF12B70-FCDA-45B6-8265-91C62AD6C63B}" dt="2026-05-02T18:25:26.498" v="194" actId="26606"/>
-          <ac:spMkLst>
-            <pc:docMk/>
-            <pc:sldMk cId="2044519959" sldId="258"/>
-            <ac:spMk id="16" creationId="{C359E835-CE77-4DCC-8EC3-1924094D3B5B}"/>
-          </ac:spMkLst>
-        </pc:spChg>
         <pc:graphicFrameChg chg="add mod modGraphic">
           <ac:chgData name="_ Nyabuto" userId="de7d4a1065fab06a" providerId="LiveId" clId="{1DF12B70-FCDA-45B6-8265-91C62AD6C63B}" dt="2026-05-02T23:03:25.374" v="1687"/>
           <ac:graphicFrameMkLst>
@@ -244,22 +204,6 @@
             <ac:graphicFrameMk id="5" creationId="{32F16B7D-7C10-45CD-65E6-879F5A7BBF4E}"/>
           </ac:graphicFrameMkLst>
         </pc:graphicFrameChg>
-        <pc:picChg chg="add del">
-          <ac:chgData name="_ Nyabuto" userId="de7d4a1065fab06a" providerId="LiveId" clId="{1DF12B70-FCDA-45B6-8265-91C62AD6C63B}" dt="2026-05-02T18:25:04.661" v="192" actId="26606"/>
-          <ac:picMkLst>
-            <pc:docMk/>
-            <pc:sldMk cId="2044519959" sldId="258"/>
-            <ac:picMk id="10" creationId="{21CB8282-44AF-40D0-A7E2-03734788DC49}"/>
-          </ac:picMkLst>
-        </pc:picChg>
-        <pc:picChg chg="add del">
-          <ac:chgData name="_ Nyabuto" userId="de7d4a1065fab06a" providerId="LiveId" clId="{1DF12B70-FCDA-45B6-8265-91C62AD6C63B}" dt="2026-05-02T18:25:26.498" v="194" actId="26606"/>
-          <ac:picMkLst>
-            <pc:docMk/>
-            <pc:sldMk cId="2044519959" sldId="258"/>
-            <ac:picMk id="14" creationId="{B03B59B5-123A-4DC5-87BD-6D3E22FA6504}"/>
-          </ac:picMkLst>
-        </pc:picChg>
       </pc:sldChg>
       <pc:sldChg chg="modSp mod">
         <pc:chgData name="_ Nyabuto" userId="de7d4a1065fab06a" providerId="LiveId" clId="{1DF12B70-FCDA-45B6-8265-91C62AD6C63B}" dt="2026-05-02T23:01:48.568" v="1671" actId="207"/>
@@ -353,29 +297,6 @@
           </ac:spMkLst>
         </pc:spChg>
       </pc:sldChg>
-      <pc:sldChg chg="modSp add del mod">
-        <pc:chgData name="_ Nyabuto" userId="de7d4a1065fab06a" providerId="LiveId" clId="{1DF12B70-FCDA-45B6-8265-91C62AD6C63B}" dt="2026-05-02T18:41:36.208" v="216" actId="2696"/>
-        <pc:sldMkLst>
-          <pc:docMk/>
-          <pc:sldMk cId="2093934568" sldId="263"/>
-        </pc:sldMkLst>
-        <pc:spChg chg="mod">
-          <ac:chgData name="_ Nyabuto" userId="de7d4a1065fab06a" providerId="LiveId" clId="{1DF12B70-FCDA-45B6-8265-91C62AD6C63B}" dt="2026-05-02T18:41:27.629" v="214" actId="21"/>
-          <ac:spMkLst>
-            <pc:docMk/>
-            <pc:sldMk cId="2093934568" sldId="263"/>
-            <ac:spMk id="2" creationId="{8477A0A7-3C82-6413-58F4-490A54DFA35D}"/>
-          </ac:spMkLst>
-        </pc:spChg>
-        <pc:graphicFrameChg chg="mod ord">
-          <ac:chgData name="_ Nyabuto" userId="de7d4a1065fab06a" providerId="LiveId" clId="{1DF12B70-FCDA-45B6-8265-91C62AD6C63B}" dt="2026-05-02T18:40:56.209" v="211"/>
-          <ac:graphicFrameMkLst>
-            <pc:docMk/>
-            <pc:sldMk cId="2093934568" sldId="263"/>
-            <ac:graphicFrameMk id="5" creationId="{5F7FFE0E-DFD5-4A50-324C-864ED9511AAD}"/>
-          </ac:graphicFrameMkLst>
-        </pc:graphicFrameChg>
-      </pc:sldChg>
       <pc:sldChg chg="modSp new mod">
         <pc:chgData name="_ Nyabuto" userId="de7d4a1065fab06a" providerId="LiveId" clId="{1DF12B70-FCDA-45B6-8265-91C62AD6C63B}" dt="2026-05-02T23:03:42.665" v="1689" actId="207"/>
         <pc:sldMkLst>
@@ -398,13 +319,6 @@
             <ac:spMk id="3" creationId="{5629CD50-D47C-5FA5-DDE5-AF86A12F2A7F}"/>
           </ac:spMkLst>
         </pc:spChg>
-      </pc:sldChg>
-      <pc:sldChg chg="add del">
-        <pc:chgData name="_ Nyabuto" userId="de7d4a1065fab06a" providerId="LiveId" clId="{1DF12B70-FCDA-45B6-8265-91C62AD6C63B}" dt="2026-05-02T23:04:22.519" v="1692" actId="2696"/>
-        <pc:sldMkLst>
-          <pc:docMk/>
-          <pc:sldMk cId="2378101939" sldId="265"/>
-        </pc:sldMkLst>
       </pc:sldChg>
       <pc:sldMasterChg chg="setBg modSldLayout">
         <pc:chgData name="_ Nyabuto" userId="de7d4a1065fab06a" providerId="LiveId" clId="{1DF12B70-FCDA-45B6-8265-91C62AD6C63B}" dt="2026-05-02T22:58:24.242" v="1656"/>
@@ -3642,7 +3556,7 @@
           <a:p>
             <a:fld id="{48A87A34-81AB-432B-8DAE-1953F412C126}" type="datetimeFigureOut">
               <a:rPr lang="en-US" dirty="0"/>
-              <a:t>5/2/2026</a:t>
+              <a:t>5/21/2026</a:t>
             </a:fld>
             <a:endParaRPr lang="en-US" dirty="0"/>
           </a:p>
@@ -3949,7 +3863,7 @@
           <a:p>
             <a:fld id="{48A87A34-81AB-432B-8DAE-1953F412C126}" type="datetimeFigureOut">
               <a:rPr lang="en-US" dirty="0"/>
-              <a:t>5/2/2026</a:t>
+              <a:t>5/21/2026</a:t>
             </a:fld>
             <a:endParaRPr lang="en-US" dirty="0"/>
           </a:p>
@@ -4166,7 +4080,7 @@
           <a:p>
             <a:fld id="{48A87A34-81AB-432B-8DAE-1953F412C126}" type="datetimeFigureOut">
               <a:rPr lang="en-US" dirty="0"/>
-              <a:t>5/2/2026</a:t>
+              <a:t>5/21/2026</a:t>
             </a:fld>
             <a:endParaRPr lang="en-US" dirty="0"/>
           </a:p>
@@ -4452,7 +4366,7 @@
           <a:p>
             <a:fld id="{48A87A34-81AB-432B-8DAE-1953F412C126}" type="datetimeFigureOut">
               <a:rPr lang="en-US" dirty="0"/>
-              <a:t>5/2/2026</a:t>
+              <a:t>5/21/2026</a:t>
             </a:fld>
             <a:endParaRPr lang="en-US" dirty="0"/>
           </a:p>
@@ -4901,7 +4815,7 @@
           <a:p>
             <a:fld id="{48A87A34-81AB-432B-8DAE-1953F412C126}" type="datetimeFigureOut">
               <a:rPr lang="en-US" dirty="0"/>
-              <a:t>5/2/2026</a:t>
+              <a:t>5/21/2026</a:t>
             </a:fld>
             <a:endParaRPr lang="en-US" dirty="0"/>
           </a:p>
@@ -5472,7 +5386,7 @@
           <a:p>
             <a:fld id="{48A87A34-81AB-432B-8DAE-1953F412C126}" type="datetimeFigureOut">
               <a:rPr lang="en-US" dirty="0"/>
-              <a:t>5/2/2026</a:t>
+              <a:t>5/21/2026</a:t>
             </a:fld>
             <a:endParaRPr lang="en-US" dirty="0"/>
           </a:p>
@@ -6319,7 +6233,7 @@
           <a:p>
             <a:fld id="{48A87A34-81AB-432B-8DAE-1953F412C126}" type="datetimeFigureOut">
               <a:rPr lang="en-US" dirty="0"/>
-              <a:t>5/2/2026</a:t>
+              <a:t>5/21/2026</a:t>
             </a:fld>
             <a:endParaRPr lang="en-US" dirty="0"/>
           </a:p>
@@ -6519,7 +6433,7 @@
           <a:p>
             <a:fld id="{48A87A34-81AB-432B-8DAE-1953F412C126}" type="datetimeFigureOut">
               <a:rPr lang="en-US" dirty="0"/>
-              <a:t>5/2/2026</a:t>
+              <a:t>5/21/2026</a:t>
             </a:fld>
             <a:endParaRPr lang="en-US" dirty="0"/>
           </a:p>
@@ -6728,7 +6642,7 @@
           <a:p>
             <a:fld id="{48A87A34-81AB-432B-8DAE-1953F412C126}" type="datetimeFigureOut">
               <a:rPr lang="en-US" dirty="0"/>
-              <a:t>5/2/2026</a:t>
+              <a:t>5/21/2026</a:t>
             </a:fld>
             <a:endParaRPr lang="en-US" dirty="0"/>
           </a:p>
@@ -6928,7 +6842,7 @@
           <a:p>
             <a:fld id="{48A87A34-81AB-432B-8DAE-1953F412C126}" type="datetimeFigureOut">
               <a:rPr lang="en-US" dirty="0"/>
-              <a:t>5/2/2026</a:t>
+              <a:t>5/21/2026</a:t>
             </a:fld>
             <a:endParaRPr lang="en-US" dirty="0"/>
           </a:p>
@@ -7203,7 +7117,7 @@
           <a:p>
             <a:fld id="{48A87A34-81AB-432B-8DAE-1953F412C126}" type="datetimeFigureOut">
               <a:rPr lang="en-US" dirty="0"/>
-              <a:t>5/2/2026</a:t>
+              <a:t>5/21/2026</a:t>
             </a:fld>
             <a:endParaRPr lang="en-US" dirty="0"/>
           </a:p>
@@ -7465,7 +7379,7 @@
           <a:p>
             <a:fld id="{48A87A34-81AB-432B-8DAE-1953F412C126}" type="datetimeFigureOut">
               <a:rPr lang="en-US" dirty="0"/>
-              <a:t>5/2/2026</a:t>
+              <a:t>5/21/2026</a:t>
             </a:fld>
             <a:endParaRPr lang="en-US" dirty="0"/>
           </a:p>
@@ -7875,7 +7789,7 @@
           <a:p>
             <a:fld id="{48A87A34-81AB-432B-8DAE-1953F412C126}" type="datetimeFigureOut">
               <a:rPr lang="en-US" dirty="0"/>
-              <a:t>5/2/2026</a:t>
+              <a:t>5/21/2026</a:t>
             </a:fld>
             <a:endParaRPr lang="en-US" dirty="0"/>
           </a:p>
@@ -8018,7 +7932,7 @@
           <a:p>
             <a:fld id="{48A87A34-81AB-432B-8DAE-1953F412C126}" type="datetimeFigureOut">
               <a:rPr lang="en-US" dirty="0"/>
-              <a:t>5/2/2026</a:t>
+              <a:t>5/21/2026</a:t>
             </a:fld>
             <a:endParaRPr lang="en-US" dirty="0"/>
           </a:p>
@@ -8138,7 +8052,7 @@
           <a:p>
             <a:fld id="{48A87A34-81AB-432B-8DAE-1953F412C126}" type="datetimeFigureOut">
               <a:rPr lang="en-US" dirty="0"/>
-              <a:t>5/2/2026</a:t>
+              <a:t>5/21/2026</a:t>
             </a:fld>
             <a:endParaRPr lang="en-US" dirty="0"/>
           </a:p>
@@ -8412,7 +8326,7 @@
           <a:p>
             <a:fld id="{48A87A34-81AB-432B-8DAE-1953F412C126}" type="datetimeFigureOut">
               <a:rPr lang="en-US" dirty="0"/>
-              <a:t>5/2/2026</a:t>
+              <a:t>5/21/2026</a:t>
             </a:fld>
             <a:endParaRPr lang="en-US" dirty="0"/>
           </a:p>
@@ -8719,7 +8633,7 @@
           <a:p>
             <a:fld id="{48A87A34-81AB-432B-8DAE-1953F412C126}" type="datetimeFigureOut">
               <a:rPr lang="en-US" dirty="0"/>
-              <a:t>5/2/2026</a:t>
+              <a:t>5/21/2026</a:t>
             </a:fld>
             <a:endParaRPr lang="en-US" dirty="0"/>
           </a:p>
@@ -8998,7 +8912,7 @@
             <a:fld id="{48A87A34-81AB-432B-8DAE-1953F412C126}" type="datetimeFigureOut">
               <a:rPr lang="en-US" dirty="0"/>
               <a:pPr/>
-              <a:t>5/2/2026</a:t>
+              <a:t>5/21/2026</a:t>
             </a:fld>
             <a:endParaRPr lang="en-US" dirty="0"/>
           </a:p>
@@ -11798,4 +11712,26 @@
     </a:ext>
   </a:extLst>
 </a:theme>
+</file>
+
+<file path=ppt/webextensions/taskpanes.xml><?xml version="1.0" encoding="utf-8"?>
+<wetp:taskpanes xmlns:wetp="http://schemas.microsoft.com/office/webextensions/taskpanes/2010/11">
+  <wetp:taskpane dockstate="right" visibility="0" width="525" row="1">
+    <wetp:webextensionref xmlns:r="http://schemas.openxmlformats.org/officeDocument/2006/relationships" r:id="rId1"/>
+  </wetp:taskpane>
+</wetp:taskpanes>
+</file>
+
+<file path=ppt/webextensions/webextension1.xml><?xml version="1.0" encoding="utf-8"?>
+<we:webextension xmlns:we="http://schemas.microsoft.com/office/webextensions/webextension/2010/11" id="{B4EDD607-FCD3-46D6-82FF-A8F309ABA5C8}">
+  <we:reference id="wa200010725" version="1.0.0.1" store="en-US" storeType="OMEX"/>
+  <we:alternateReferences>
+    <we:reference id="wa200010725" version="1.0.0.1" store="" storeType="OMEX"/>
+  </we:alternateReferences>
+  <we:properties>
+    <we:property name="claude.fileId" value="&quot;0db070dd-08c1-4c17-83c9-2af18cb14ede&quot;"/>
+  </we:properties>
+  <we:bindings/>
+  <we:snapshot xmlns:r="http://schemas.openxmlformats.org/officeDocument/2006/relationships"/>
+</we:webextension>
 </file>
</xml_diff>

<commit_message>
Add Retail Sales Project
</commit_message>
<xml_diff>
--- a/PowerBI Assignment/Group 14 Tembo Hotel Presentation.pptx
+++ b/PowerBI Assignment/Group 14 Tembo Hotel Presentation.pptx
@@ -122,7 +122,7 @@
 <file path=ppt/revisionInfo.xml><?xml version="1.0" encoding="utf-8"?>
 <p1510:revInfo xmlns:a="http://schemas.openxmlformats.org/drawingml/2006/main" xmlns:r="http://schemas.openxmlformats.org/officeDocument/2006/relationships" xmlns:p1510="http://schemas.microsoft.com/office/powerpoint/2015/10/main">
   <p1510:revLst>
-    <p1510:client id="{866A2317-32B2-4D6D-99C4-47E5FE503A5E}" v="167" dt="2026-05-02T23:03:25.374"/>
+    <p1510:client id="{866A2317-32B2-4D6D-99C4-47E5FE503A5E}" v="168" dt="2026-05-21T17:16:09.332"/>
   </p1510:revLst>
 </p1510:revInfo>
 </file>
@@ -156,14 +156,6 @@
             <pc:docMk/>
             <pc:sldMk cId="3652765744" sldId="256"/>
             <ac:spMk id="3" creationId="{E81F8283-6937-49E8-ACC2-CCFEDDDE032E}"/>
-          </ac:spMkLst>
-        </pc:spChg>
-        <pc:spChg chg="add del mod">
-          <ac:chgData name="_ Nyabuto" userId="de7d4a1065fab06a" providerId="LiveId" clId="{1DF12B70-FCDA-45B6-8265-91C62AD6C63B}" dt="2026-05-02T23:01:05.585" v="1665" actId="478"/>
-          <ac:spMkLst>
-            <pc:docMk/>
-            <pc:sldMk cId="3652765744" sldId="256"/>
-            <ac:spMk id="5" creationId="{D3CAC3DD-4B1E-2D3C-5798-6AA1099F088F}"/>
           </ac:spMkLst>
         </pc:spChg>
       </pc:sldChg>
@@ -204,38 +196,6 @@
             <ac:spMk id="2" creationId="{0BEDEBDF-C82A-4B40-9FDA-B9E873A3FB01}"/>
           </ac:spMkLst>
         </pc:spChg>
-        <pc:spChg chg="del">
-          <ac:chgData name="_ Nyabuto" userId="de7d4a1065fab06a" providerId="LiveId" clId="{1DF12B70-FCDA-45B6-8265-91C62AD6C63B}" dt="2026-05-02T18:13:42.569" v="0" actId="26606"/>
-          <ac:spMkLst>
-            <pc:docMk/>
-            <pc:sldMk cId="2044519959" sldId="258"/>
-            <ac:spMk id="3" creationId="{1A28688F-4289-4AF9-9334-6886D45BD6C7}"/>
-          </ac:spMkLst>
-        </pc:spChg>
-        <pc:spChg chg="add del">
-          <ac:chgData name="_ Nyabuto" userId="de7d4a1065fab06a" providerId="LiveId" clId="{1DF12B70-FCDA-45B6-8265-91C62AD6C63B}" dt="2026-05-02T18:25:04.661" v="192" actId="26606"/>
-          <ac:spMkLst>
-            <pc:docMk/>
-            <pc:sldMk cId="2044519959" sldId="258"/>
-            <ac:spMk id="12" creationId="{D77CF7D5-36A3-4ED3-AE46-77E42D2AA7FD}"/>
-          </ac:spMkLst>
-        </pc:spChg>
-        <pc:spChg chg="add del">
-          <ac:chgData name="_ Nyabuto" userId="de7d4a1065fab06a" providerId="LiveId" clId="{1DF12B70-FCDA-45B6-8265-91C62AD6C63B}" dt="2026-05-02T18:25:26.498" v="194" actId="26606"/>
-          <ac:spMkLst>
-            <pc:docMk/>
-            <pc:sldMk cId="2044519959" sldId="258"/>
-            <ac:spMk id="15" creationId="{6D58954F-C5AC-4BE0-811D-8DFE18E3506B}"/>
-          </ac:spMkLst>
-        </pc:spChg>
-        <pc:spChg chg="add del">
-          <ac:chgData name="_ Nyabuto" userId="de7d4a1065fab06a" providerId="LiveId" clId="{1DF12B70-FCDA-45B6-8265-91C62AD6C63B}" dt="2026-05-02T18:25:26.498" v="194" actId="26606"/>
-          <ac:spMkLst>
-            <pc:docMk/>
-            <pc:sldMk cId="2044519959" sldId="258"/>
-            <ac:spMk id="16" creationId="{C359E835-CE77-4DCC-8EC3-1924094D3B5B}"/>
-          </ac:spMkLst>
-        </pc:spChg>
         <pc:graphicFrameChg chg="add mod modGraphic">
           <ac:chgData name="_ Nyabuto" userId="de7d4a1065fab06a" providerId="LiveId" clId="{1DF12B70-FCDA-45B6-8265-91C62AD6C63B}" dt="2026-05-02T23:03:25.374" v="1687"/>
           <ac:graphicFrameMkLst>
@@ -244,22 +204,6 @@
             <ac:graphicFrameMk id="5" creationId="{32F16B7D-7C10-45CD-65E6-879F5A7BBF4E}"/>
           </ac:graphicFrameMkLst>
         </pc:graphicFrameChg>
-        <pc:picChg chg="add del">
-          <ac:chgData name="_ Nyabuto" userId="de7d4a1065fab06a" providerId="LiveId" clId="{1DF12B70-FCDA-45B6-8265-91C62AD6C63B}" dt="2026-05-02T18:25:04.661" v="192" actId="26606"/>
-          <ac:picMkLst>
-            <pc:docMk/>
-            <pc:sldMk cId="2044519959" sldId="258"/>
-            <ac:picMk id="10" creationId="{21CB8282-44AF-40D0-A7E2-03734788DC49}"/>
-          </ac:picMkLst>
-        </pc:picChg>
-        <pc:picChg chg="add del">
-          <ac:chgData name="_ Nyabuto" userId="de7d4a1065fab06a" providerId="LiveId" clId="{1DF12B70-FCDA-45B6-8265-91C62AD6C63B}" dt="2026-05-02T18:25:26.498" v="194" actId="26606"/>
-          <ac:picMkLst>
-            <pc:docMk/>
-            <pc:sldMk cId="2044519959" sldId="258"/>
-            <ac:picMk id="14" creationId="{B03B59B5-123A-4DC5-87BD-6D3E22FA6504}"/>
-          </ac:picMkLst>
-        </pc:picChg>
       </pc:sldChg>
       <pc:sldChg chg="modSp mod">
         <pc:chgData name="_ Nyabuto" userId="de7d4a1065fab06a" providerId="LiveId" clId="{1DF12B70-FCDA-45B6-8265-91C62AD6C63B}" dt="2026-05-02T23:01:48.568" v="1671" actId="207"/>
@@ -353,29 +297,6 @@
           </ac:spMkLst>
         </pc:spChg>
       </pc:sldChg>
-      <pc:sldChg chg="modSp add del mod">
-        <pc:chgData name="_ Nyabuto" userId="de7d4a1065fab06a" providerId="LiveId" clId="{1DF12B70-FCDA-45B6-8265-91C62AD6C63B}" dt="2026-05-02T18:41:36.208" v="216" actId="2696"/>
-        <pc:sldMkLst>
-          <pc:docMk/>
-          <pc:sldMk cId="2093934568" sldId="263"/>
-        </pc:sldMkLst>
-        <pc:spChg chg="mod">
-          <ac:chgData name="_ Nyabuto" userId="de7d4a1065fab06a" providerId="LiveId" clId="{1DF12B70-FCDA-45B6-8265-91C62AD6C63B}" dt="2026-05-02T18:41:27.629" v="214" actId="21"/>
-          <ac:spMkLst>
-            <pc:docMk/>
-            <pc:sldMk cId="2093934568" sldId="263"/>
-            <ac:spMk id="2" creationId="{8477A0A7-3C82-6413-58F4-490A54DFA35D}"/>
-          </ac:spMkLst>
-        </pc:spChg>
-        <pc:graphicFrameChg chg="mod ord">
-          <ac:chgData name="_ Nyabuto" userId="de7d4a1065fab06a" providerId="LiveId" clId="{1DF12B70-FCDA-45B6-8265-91C62AD6C63B}" dt="2026-05-02T18:40:56.209" v="211"/>
-          <ac:graphicFrameMkLst>
-            <pc:docMk/>
-            <pc:sldMk cId="2093934568" sldId="263"/>
-            <ac:graphicFrameMk id="5" creationId="{5F7FFE0E-DFD5-4A50-324C-864ED9511AAD}"/>
-          </ac:graphicFrameMkLst>
-        </pc:graphicFrameChg>
-      </pc:sldChg>
       <pc:sldChg chg="modSp new mod">
         <pc:chgData name="_ Nyabuto" userId="de7d4a1065fab06a" providerId="LiveId" clId="{1DF12B70-FCDA-45B6-8265-91C62AD6C63B}" dt="2026-05-02T23:03:42.665" v="1689" actId="207"/>
         <pc:sldMkLst>
@@ -398,13 +319,6 @@
             <ac:spMk id="3" creationId="{5629CD50-D47C-5FA5-DDE5-AF86A12F2A7F}"/>
           </ac:spMkLst>
         </pc:spChg>
-      </pc:sldChg>
-      <pc:sldChg chg="add del">
-        <pc:chgData name="_ Nyabuto" userId="de7d4a1065fab06a" providerId="LiveId" clId="{1DF12B70-FCDA-45B6-8265-91C62AD6C63B}" dt="2026-05-02T23:04:22.519" v="1692" actId="2696"/>
-        <pc:sldMkLst>
-          <pc:docMk/>
-          <pc:sldMk cId="2378101939" sldId="265"/>
-        </pc:sldMkLst>
       </pc:sldChg>
       <pc:sldMasterChg chg="setBg modSldLayout">
         <pc:chgData name="_ Nyabuto" userId="de7d4a1065fab06a" providerId="LiveId" clId="{1DF12B70-FCDA-45B6-8265-91C62AD6C63B}" dt="2026-05-02T22:58:24.242" v="1656"/>
@@ -3642,7 +3556,7 @@
           <a:p>
             <a:fld id="{48A87A34-81AB-432B-8DAE-1953F412C126}" type="datetimeFigureOut">
               <a:rPr lang="en-US" dirty="0"/>
-              <a:t>5/2/2026</a:t>
+              <a:t>5/21/2026</a:t>
             </a:fld>
             <a:endParaRPr lang="en-US" dirty="0"/>
           </a:p>
@@ -3949,7 +3863,7 @@
           <a:p>
             <a:fld id="{48A87A34-81AB-432B-8DAE-1953F412C126}" type="datetimeFigureOut">
               <a:rPr lang="en-US" dirty="0"/>
-              <a:t>5/2/2026</a:t>
+              <a:t>5/21/2026</a:t>
             </a:fld>
             <a:endParaRPr lang="en-US" dirty="0"/>
           </a:p>
@@ -4166,7 +4080,7 @@
           <a:p>
             <a:fld id="{48A87A34-81AB-432B-8DAE-1953F412C126}" type="datetimeFigureOut">
               <a:rPr lang="en-US" dirty="0"/>
-              <a:t>5/2/2026</a:t>
+              <a:t>5/21/2026</a:t>
             </a:fld>
             <a:endParaRPr lang="en-US" dirty="0"/>
           </a:p>
@@ -4452,7 +4366,7 @@
           <a:p>
             <a:fld id="{48A87A34-81AB-432B-8DAE-1953F412C126}" type="datetimeFigureOut">
               <a:rPr lang="en-US" dirty="0"/>
-              <a:t>5/2/2026</a:t>
+              <a:t>5/21/2026</a:t>
             </a:fld>
             <a:endParaRPr lang="en-US" dirty="0"/>
           </a:p>
@@ -4901,7 +4815,7 @@
           <a:p>
             <a:fld id="{48A87A34-81AB-432B-8DAE-1953F412C126}" type="datetimeFigureOut">
               <a:rPr lang="en-US" dirty="0"/>
-              <a:t>5/2/2026</a:t>
+              <a:t>5/21/2026</a:t>
             </a:fld>
             <a:endParaRPr lang="en-US" dirty="0"/>
           </a:p>
@@ -5472,7 +5386,7 @@
           <a:p>
             <a:fld id="{48A87A34-81AB-432B-8DAE-1953F412C126}" type="datetimeFigureOut">
               <a:rPr lang="en-US" dirty="0"/>
-              <a:t>5/2/2026</a:t>
+              <a:t>5/21/2026</a:t>
             </a:fld>
             <a:endParaRPr lang="en-US" dirty="0"/>
           </a:p>
@@ -6319,7 +6233,7 @@
           <a:p>
             <a:fld id="{48A87A34-81AB-432B-8DAE-1953F412C126}" type="datetimeFigureOut">
               <a:rPr lang="en-US" dirty="0"/>
-              <a:t>5/2/2026</a:t>
+              <a:t>5/21/2026</a:t>
             </a:fld>
             <a:endParaRPr lang="en-US" dirty="0"/>
           </a:p>
@@ -6519,7 +6433,7 @@
           <a:p>
             <a:fld id="{48A87A34-81AB-432B-8DAE-1953F412C126}" type="datetimeFigureOut">
               <a:rPr lang="en-US" dirty="0"/>
-              <a:t>5/2/2026</a:t>
+              <a:t>5/21/2026</a:t>
             </a:fld>
             <a:endParaRPr lang="en-US" dirty="0"/>
           </a:p>
@@ -6728,7 +6642,7 @@
           <a:p>
             <a:fld id="{48A87A34-81AB-432B-8DAE-1953F412C126}" type="datetimeFigureOut">
               <a:rPr lang="en-US" dirty="0"/>
-              <a:t>5/2/2026</a:t>
+              <a:t>5/21/2026</a:t>
             </a:fld>
             <a:endParaRPr lang="en-US" dirty="0"/>
           </a:p>
@@ -6928,7 +6842,7 @@
           <a:p>
             <a:fld id="{48A87A34-81AB-432B-8DAE-1953F412C126}" type="datetimeFigureOut">
               <a:rPr lang="en-US" dirty="0"/>
-              <a:t>5/2/2026</a:t>
+              <a:t>5/21/2026</a:t>
             </a:fld>
             <a:endParaRPr lang="en-US" dirty="0"/>
           </a:p>
@@ -7203,7 +7117,7 @@
           <a:p>
             <a:fld id="{48A87A34-81AB-432B-8DAE-1953F412C126}" type="datetimeFigureOut">
               <a:rPr lang="en-US" dirty="0"/>
-              <a:t>5/2/2026</a:t>
+              <a:t>5/21/2026</a:t>
             </a:fld>
             <a:endParaRPr lang="en-US" dirty="0"/>
           </a:p>
@@ -7465,7 +7379,7 @@
           <a:p>
             <a:fld id="{48A87A34-81AB-432B-8DAE-1953F412C126}" type="datetimeFigureOut">
               <a:rPr lang="en-US" dirty="0"/>
-              <a:t>5/2/2026</a:t>
+              <a:t>5/21/2026</a:t>
             </a:fld>
             <a:endParaRPr lang="en-US" dirty="0"/>
           </a:p>
@@ -7875,7 +7789,7 @@
           <a:p>
             <a:fld id="{48A87A34-81AB-432B-8DAE-1953F412C126}" type="datetimeFigureOut">
               <a:rPr lang="en-US" dirty="0"/>
-              <a:t>5/2/2026</a:t>
+              <a:t>5/21/2026</a:t>
             </a:fld>
             <a:endParaRPr lang="en-US" dirty="0"/>
           </a:p>
@@ -8018,7 +7932,7 @@
           <a:p>
             <a:fld id="{48A87A34-81AB-432B-8DAE-1953F412C126}" type="datetimeFigureOut">
               <a:rPr lang="en-US" dirty="0"/>
-              <a:t>5/2/2026</a:t>
+              <a:t>5/21/2026</a:t>
             </a:fld>
             <a:endParaRPr lang="en-US" dirty="0"/>
           </a:p>
@@ -8138,7 +8052,7 @@
           <a:p>
             <a:fld id="{48A87A34-81AB-432B-8DAE-1953F412C126}" type="datetimeFigureOut">
               <a:rPr lang="en-US" dirty="0"/>
-              <a:t>5/2/2026</a:t>
+              <a:t>5/21/2026</a:t>
             </a:fld>
             <a:endParaRPr lang="en-US" dirty="0"/>
           </a:p>
@@ -8412,7 +8326,7 @@
           <a:p>
             <a:fld id="{48A87A34-81AB-432B-8DAE-1953F412C126}" type="datetimeFigureOut">
               <a:rPr lang="en-US" dirty="0"/>
-              <a:t>5/2/2026</a:t>
+              <a:t>5/21/2026</a:t>
             </a:fld>
             <a:endParaRPr lang="en-US" dirty="0"/>
           </a:p>
@@ -8719,7 +8633,7 @@
           <a:p>
             <a:fld id="{48A87A34-81AB-432B-8DAE-1953F412C126}" type="datetimeFigureOut">
               <a:rPr lang="en-US" dirty="0"/>
-              <a:t>5/2/2026</a:t>
+              <a:t>5/21/2026</a:t>
             </a:fld>
             <a:endParaRPr lang="en-US" dirty="0"/>
           </a:p>
@@ -8998,7 +8912,7 @@
             <a:fld id="{48A87A34-81AB-432B-8DAE-1953F412C126}" type="datetimeFigureOut">
               <a:rPr lang="en-US" dirty="0"/>
               <a:pPr/>
-              <a:t>5/2/2026</a:t>
+              <a:t>5/21/2026</a:t>
             </a:fld>
             <a:endParaRPr lang="en-US" dirty="0"/>
           </a:p>
@@ -11798,4 +11712,26 @@
     </a:ext>
   </a:extLst>
 </a:theme>
+</file>
+
+<file path=ppt/webextensions/taskpanes.xml><?xml version="1.0" encoding="utf-8"?>
+<wetp:taskpanes xmlns:wetp="http://schemas.microsoft.com/office/webextensions/taskpanes/2010/11">
+  <wetp:taskpane dockstate="right" visibility="0" width="525" row="1">
+    <wetp:webextensionref xmlns:r="http://schemas.openxmlformats.org/officeDocument/2006/relationships" r:id="rId1"/>
+  </wetp:taskpane>
+</wetp:taskpanes>
+</file>
+
+<file path=ppt/webextensions/webextension1.xml><?xml version="1.0" encoding="utf-8"?>
+<we:webextension xmlns:we="http://schemas.microsoft.com/office/webextensions/webextension/2010/11" id="{B4EDD607-FCD3-46D6-82FF-A8F309ABA5C8}">
+  <we:reference id="wa200010725" version="1.0.0.1" store="en-US" storeType="OMEX"/>
+  <we:alternateReferences>
+    <we:reference id="wa200010725" version="1.0.0.1" store="" storeType="OMEX"/>
+  </we:alternateReferences>
+  <we:properties>
+    <we:property name="claude.fileId" value="&quot;0db070dd-08c1-4c17-83c9-2af18cb14ede&quot;"/>
+  </we:properties>
+  <we:bindings/>
+  <we:snapshot xmlns:r="http://schemas.openxmlformats.org/officeDocument/2006/relationships"/>
+</we:webextension>
 </file>
</xml_diff>